<commit_message>
update layout and styles
</commit_message>
<xml_diff>
--- a/ALK-presentation.pptx
+++ b/ALK-presentation.pptx
@@ -3511,7 +3511,7 @@
         </p:nvSpPr>
         <p:spPr>
           <a:xfrm>
-            <a:off x="457200" y="3227832"/>
+            <a:off x="457200" y="3246120"/>
             <a:ext cx="457200" cy="457200"/>
           </a:xfrm>
           <a:prstGeom prst="rect">
@@ -3660,7 +3660,7 @@
         </p:nvSpPr>
         <p:spPr>
           <a:xfrm>
-            <a:off x="3291840" y="3227832"/>
+            <a:off x="3291840" y="3246120"/>
             <a:ext cx="457200" cy="457200"/>
           </a:xfrm>
           <a:prstGeom prst="rect">
@@ -3809,7 +3809,7 @@
         </p:nvSpPr>
         <p:spPr>
           <a:xfrm>
-            <a:off x="6126480" y="3227832"/>
+            <a:off x="6126480" y="3246120"/>
             <a:ext cx="457200" cy="457200"/>
           </a:xfrm>
           <a:prstGeom prst="rect">
@@ -5475,7 +5475,29 @@
                 <a:ea typeface="Calibri" pitchFamily="34" charset="-122"/>
                 <a:cs typeface="Calibri" pitchFamily="34" charset="-120"/>
               </a:rPr>
-              <a:t>Pourquoi un bon site web est vital en 2024</a:t>
+              <a:t>Pourquoi un bon site web est vital </a:t>
+            </a:r>
+            <a:r>
+              <a:rPr lang="en-US" sz="900" dirty="0" err="1">
+                <a:solidFill>
+                  <a:srgbClr val="8A96A0"/>
+                </a:solidFill>
+                <a:latin typeface="Calibri" pitchFamily="34" charset="0"/>
+                <a:ea typeface="Calibri" pitchFamily="34" charset="-122"/>
+                <a:cs typeface="Calibri" pitchFamily="34" charset="-120"/>
+              </a:rPr>
+              <a:t>en</a:t>
+            </a:r>
+            <a:r>
+              <a:rPr lang="en-US" sz="900" dirty="0">
+                <a:solidFill>
+                  <a:srgbClr val="8A96A0"/>
+                </a:solidFill>
+                <a:latin typeface="Calibri" pitchFamily="34" charset="0"/>
+                <a:ea typeface="Calibri" pitchFamily="34" charset="-122"/>
+                <a:cs typeface="Calibri" pitchFamily="34" charset="-120"/>
+              </a:rPr>
+              <a:t> 2026</a:t>
             </a:r>
             <a:endParaRPr lang="en-US" sz="900" dirty="0"/>
           </a:p>
@@ -10052,7 +10074,7 @@
                 <a:ea typeface="Calibri" pitchFamily="34" charset="-122"/>
                 <a:cs typeface="Calibri" pitchFamily="34" charset="-120"/>
               </a:rPr>
-              <a:t>— Non adapté aux smartphones</a:t>
+              <a:t>— Non adapté aux smartphones/desktop</a:t>
             </a:r>
             <a:endParaRPr lang="en-US" sz="950" dirty="0"/>
           </a:p>

</xml_diff>